<commit_message>
Retrieving The Authenticated User
</commit_message>
<xml_diff>
--- a/.lessons/28 Fundamental Authentication/3 Retrieving The Authenticated User/1.pptx
+++ b/.lessons/28 Fundamental Authentication/3 Retrieving The Authenticated User/1.pptx
@@ -261,7 +261,7 @@
           <a:p>
             <a:fld id="{3E102D2E-813C-461C-9963-687A650C48C0}" type="datetimeFigureOut">
               <a:rPr lang="en-US" smtClean="0"/>
-              <a:t>5/23/2025</a:t>
+              <a:t>6/1/2025</a:t>
             </a:fld>
             <a:endParaRPr lang="en-US"/>
           </a:p>
@@ -459,7 +459,7 @@
           <a:p>
             <a:fld id="{3E102D2E-813C-461C-9963-687A650C48C0}" type="datetimeFigureOut">
               <a:rPr lang="en-US" smtClean="0"/>
-              <a:t>5/23/2025</a:t>
+              <a:t>6/1/2025</a:t>
             </a:fld>
             <a:endParaRPr lang="en-US"/>
           </a:p>
@@ -667,7 +667,7 @@
           <a:p>
             <a:fld id="{3E102D2E-813C-461C-9963-687A650C48C0}" type="datetimeFigureOut">
               <a:rPr lang="en-US" smtClean="0"/>
-              <a:t>5/23/2025</a:t>
+              <a:t>6/1/2025</a:t>
             </a:fld>
             <a:endParaRPr lang="en-US"/>
           </a:p>
@@ -865,7 +865,7 @@
           <a:p>
             <a:fld id="{3E102D2E-813C-461C-9963-687A650C48C0}" type="datetimeFigureOut">
               <a:rPr lang="en-US" smtClean="0"/>
-              <a:t>5/23/2025</a:t>
+              <a:t>6/1/2025</a:t>
             </a:fld>
             <a:endParaRPr lang="en-US"/>
           </a:p>
@@ -1140,7 +1140,7 @@
           <a:p>
             <a:fld id="{3E102D2E-813C-461C-9963-687A650C48C0}" type="datetimeFigureOut">
               <a:rPr lang="en-US" smtClean="0"/>
-              <a:t>5/23/2025</a:t>
+              <a:t>6/1/2025</a:t>
             </a:fld>
             <a:endParaRPr lang="en-US"/>
           </a:p>
@@ -1405,7 +1405,7 @@
           <a:p>
             <a:fld id="{3E102D2E-813C-461C-9963-687A650C48C0}" type="datetimeFigureOut">
               <a:rPr lang="en-US" smtClean="0"/>
-              <a:t>5/23/2025</a:t>
+              <a:t>6/1/2025</a:t>
             </a:fld>
             <a:endParaRPr lang="en-US"/>
           </a:p>
@@ -1817,7 +1817,7 @@
           <a:p>
             <a:fld id="{3E102D2E-813C-461C-9963-687A650C48C0}" type="datetimeFigureOut">
               <a:rPr lang="en-US" smtClean="0"/>
-              <a:t>5/23/2025</a:t>
+              <a:t>6/1/2025</a:t>
             </a:fld>
             <a:endParaRPr lang="en-US"/>
           </a:p>
@@ -1958,7 +1958,7 @@
           <a:p>
             <a:fld id="{3E102D2E-813C-461C-9963-687A650C48C0}" type="datetimeFigureOut">
               <a:rPr lang="en-US" smtClean="0"/>
-              <a:t>5/23/2025</a:t>
+              <a:t>6/1/2025</a:t>
             </a:fld>
             <a:endParaRPr lang="en-US"/>
           </a:p>
@@ -2071,7 +2071,7 @@
           <a:p>
             <a:fld id="{3E102D2E-813C-461C-9963-687A650C48C0}" type="datetimeFigureOut">
               <a:rPr lang="en-US" smtClean="0"/>
-              <a:t>5/23/2025</a:t>
+              <a:t>6/1/2025</a:t>
             </a:fld>
             <a:endParaRPr lang="en-US"/>
           </a:p>
@@ -2382,7 +2382,7 @@
           <a:p>
             <a:fld id="{3E102D2E-813C-461C-9963-687A650C48C0}" type="datetimeFigureOut">
               <a:rPr lang="en-US" smtClean="0"/>
-              <a:t>5/23/2025</a:t>
+              <a:t>6/1/2025</a:t>
             </a:fld>
             <a:endParaRPr lang="en-US"/>
           </a:p>
@@ -2670,7 +2670,7 @@
           <a:p>
             <a:fld id="{3E102D2E-813C-461C-9963-687A650C48C0}" type="datetimeFigureOut">
               <a:rPr lang="en-US" smtClean="0"/>
-              <a:t>5/23/2025</a:t>
+              <a:t>6/1/2025</a:t>
             </a:fld>
             <a:endParaRPr lang="en-US"/>
           </a:p>
@@ -2911,7 +2911,7 @@
           <a:p>
             <a:fld id="{3E102D2E-813C-461C-9963-687A650C48C0}" type="datetimeFigureOut">
               <a:rPr lang="en-US" smtClean="0"/>
-              <a:t>5/23/2025</a:t>
+              <a:t>6/1/2025</a:t>
             </a:fld>
             <a:endParaRPr lang="en-US"/>
           </a:p>
@@ -3349,7 +3349,7 @@
         <p:spPr>
           <a:xfrm>
             <a:off x="217714" y="255046"/>
-            <a:ext cx="11756571" cy="355354"/>
+            <a:ext cx="11756571" cy="5156668"/>
           </a:xfrm>
           <a:prstGeom prst="rect">
             <a:avLst/>
@@ -3368,6 +3368,19 @@
               </a:lnSpc>
               <a:buNone/>
             </a:pPr>
+            <a:r>
+              <a:rPr kumimoji="0" lang="en-US" altLang="en-US" sz="1300" b="1" i="0" u="none" strike="noStrike" cap="none" normalizeH="0" baseline="0">
+                <a:ln>
+                  <a:noFill/>
+                </a:ln>
+                <a:solidFill>
+                  <a:srgbClr val="FF0000"/>
+                </a:solidFill>
+                <a:effectLst/>
+                <a:latin typeface="Arial" panose="020B0604020202020204" pitchFamily="34" charset="0"/>
+              </a:rPr>
+              <a:t>Retrieving The Authenticated User </a:t>
+            </a:r>
             <a:r>
               <a:rPr kumimoji="0" lang="en-US" altLang="en-US" sz="1300" b="0" i="0" u="none" strike="noStrike" cap="none" normalizeH="0" baseline="0">
                 <a:ln>
@@ -3379,11 +3392,500 @@
                 <a:effectLst/>
                 <a:latin typeface="Arial" panose="020B0604020202020204" pitchFamily="34" charset="0"/>
               </a:rPr>
-              <a:t>.</a:t>
-            </a:r>
-          </a:p>
-        </p:txBody>
-      </p:sp>
+              <a:t>( Doğrulanmış İstifadəçinin Alınması )</a:t>
+            </a:r>
+            <a:endParaRPr kumimoji="0" lang="az-Latn-AZ" altLang="en-US" sz="1300" b="0" i="0" u="none" strike="noStrike" cap="none" normalizeH="0" baseline="0">
+              <a:ln>
+                <a:noFill/>
+              </a:ln>
+              <a:solidFill>
+                <a:schemeClr val="tx1"/>
+              </a:solidFill>
+              <a:effectLst/>
+              <a:latin typeface="Arial" panose="020B0604020202020204" pitchFamily="34" charset="0"/>
+            </a:endParaRPr>
+          </a:p>
+          <a:p>
+            <a:pPr>
+              <a:lnSpc>
+                <a:spcPct val="150000"/>
+              </a:lnSpc>
+              <a:buNone/>
+            </a:pPr>
+            <a:endParaRPr lang="az-Latn-AZ" altLang="en-US" sz="1300">
+              <a:latin typeface="Arial" panose="020B0604020202020204" pitchFamily="34" charset="0"/>
+            </a:endParaRPr>
+          </a:p>
+          <a:p>
+            <a:pPr>
+              <a:lnSpc>
+                <a:spcPct val="150000"/>
+              </a:lnSpc>
+              <a:buNone/>
+            </a:pPr>
+            <a:r>
+              <a:rPr kumimoji="0" lang="en-US" altLang="en-US" sz="1300" b="1" i="0" u="none" strike="noStrike" cap="none" normalizeH="0" baseline="0">
+                <a:ln>
+                  <a:noFill/>
+                </a:ln>
+                <a:solidFill>
+                  <a:schemeClr val="tx1"/>
+                </a:solidFill>
+                <a:effectLst/>
+                <a:latin typeface="Arial" panose="020B0604020202020204" pitchFamily="34" charset="0"/>
+              </a:rPr>
+              <a:t>Retrieving The Authenticated User </a:t>
+            </a:r>
+            <a:r>
+              <a:rPr kumimoji="0" lang="en-US" altLang="en-US" sz="1300" b="0" i="0" u="none" strike="noStrike" cap="none" normalizeH="0" baseline="0">
+                <a:ln>
+                  <a:noFill/>
+                </a:ln>
+                <a:solidFill>
+                  <a:schemeClr val="tx1"/>
+                </a:solidFill>
+                <a:effectLst/>
+                <a:latin typeface="Arial" panose="020B0604020202020204" pitchFamily="34" charset="0"/>
+              </a:rPr>
+              <a:t>Laravel-də autentifikasiya olunmuş (login olmuş) istifadəçidən məlumat almaq üçün istifadə olunur.</a:t>
+            </a:r>
+            <a:endParaRPr kumimoji="0" lang="az-Latn-AZ" altLang="en-US" sz="1300" b="0" i="0" u="none" strike="noStrike" cap="none" normalizeH="0" baseline="0">
+              <a:ln>
+                <a:noFill/>
+              </a:ln>
+              <a:solidFill>
+                <a:schemeClr val="tx1"/>
+              </a:solidFill>
+              <a:effectLst/>
+              <a:latin typeface="Arial" panose="020B0604020202020204" pitchFamily="34" charset="0"/>
+            </a:endParaRPr>
+          </a:p>
+          <a:p>
+            <a:pPr>
+              <a:lnSpc>
+                <a:spcPct val="150000"/>
+              </a:lnSpc>
+              <a:buNone/>
+            </a:pPr>
+            <a:endParaRPr lang="az-Latn-AZ" altLang="en-US" sz="1300">
+              <a:latin typeface="Arial" panose="020B0604020202020204" pitchFamily="34" charset="0"/>
+            </a:endParaRPr>
+          </a:p>
+          <a:p>
+            <a:pPr>
+              <a:lnSpc>
+                <a:spcPct val="150000"/>
+              </a:lnSpc>
+              <a:buNone/>
+            </a:pPr>
+            <a:endParaRPr kumimoji="0" lang="az-Latn-AZ" altLang="en-US" sz="1300" b="0" i="0" u="none" strike="noStrike" cap="none" normalizeH="0" baseline="0">
+              <a:ln>
+                <a:noFill/>
+              </a:ln>
+              <a:solidFill>
+                <a:schemeClr val="tx1"/>
+              </a:solidFill>
+              <a:effectLst/>
+              <a:latin typeface="Arial" panose="020B0604020202020204" pitchFamily="34" charset="0"/>
+            </a:endParaRPr>
+          </a:p>
+          <a:p>
+            <a:pPr>
+              <a:lnSpc>
+                <a:spcPct val="150000"/>
+              </a:lnSpc>
+              <a:buNone/>
+            </a:pPr>
+            <a:endParaRPr lang="az-Latn-AZ" altLang="en-US" sz="1300">
+              <a:latin typeface="Arial" panose="020B0604020202020204" pitchFamily="34" charset="0"/>
+            </a:endParaRPr>
+          </a:p>
+          <a:p>
+            <a:pPr>
+              <a:lnSpc>
+                <a:spcPct val="150000"/>
+              </a:lnSpc>
+              <a:buNone/>
+            </a:pPr>
+            <a:endParaRPr kumimoji="0" lang="az-Latn-AZ" altLang="en-US" sz="1300" b="0" i="0" u="none" strike="noStrike" cap="none" normalizeH="0" baseline="0">
+              <a:ln>
+                <a:noFill/>
+              </a:ln>
+              <a:solidFill>
+                <a:schemeClr val="tx1"/>
+              </a:solidFill>
+              <a:effectLst/>
+              <a:latin typeface="Arial" panose="020B0604020202020204" pitchFamily="34" charset="0"/>
+            </a:endParaRPr>
+          </a:p>
+          <a:p>
+            <a:pPr>
+              <a:lnSpc>
+                <a:spcPct val="150000"/>
+              </a:lnSpc>
+              <a:buNone/>
+            </a:pPr>
+            <a:endParaRPr lang="az-Latn-AZ" altLang="en-US" sz="1300">
+              <a:latin typeface="Arial" panose="020B0604020202020204" pitchFamily="34" charset="0"/>
+            </a:endParaRPr>
+          </a:p>
+          <a:p>
+            <a:pPr>
+              <a:lnSpc>
+                <a:spcPct val="150000"/>
+              </a:lnSpc>
+              <a:buNone/>
+            </a:pPr>
+            <a:endParaRPr kumimoji="0" lang="az-Latn-AZ" altLang="en-US" sz="1300" b="0" i="0" u="none" strike="noStrike" cap="none" normalizeH="0" baseline="0">
+              <a:ln>
+                <a:noFill/>
+              </a:ln>
+              <a:solidFill>
+                <a:schemeClr val="tx1"/>
+              </a:solidFill>
+              <a:effectLst/>
+              <a:latin typeface="Arial" panose="020B0604020202020204" pitchFamily="34" charset="0"/>
+            </a:endParaRPr>
+          </a:p>
+          <a:p>
+            <a:pPr>
+              <a:lnSpc>
+                <a:spcPct val="150000"/>
+              </a:lnSpc>
+              <a:buNone/>
+            </a:pPr>
+            <a:endParaRPr kumimoji="0" lang="az-Latn-AZ" altLang="en-US" sz="1300" b="0" i="0" u="none" strike="noStrike" cap="none" normalizeH="0" baseline="0">
+              <a:ln>
+                <a:noFill/>
+              </a:ln>
+              <a:solidFill>
+                <a:schemeClr val="tx1"/>
+              </a:solidFill>
+              <a:effectLst/>
+              <a:latin typeface="Arial" panose="020B0604020202020204" pitchFamily="34" charset="0"/>
+            </a:endParaRPr>
+          </a:p>
+          <a:p>
+            <a:pPr>
+              <a:lnSpc>
+                <a:spcPct val="150000"/>
+              </a:lnSpc>
+              <a:buNone/>
+            </a:pPr>
+            <a:r>
+              <a:rPr kumimoji="0" lang="en-US" altLang="en-US" sz="1300" b="1" i="0" u="none" strike="noStrike" cap="none" normalizeH="0" baseline="0">
+                <a:ln>
+                  <a:noFill/>
+                </a:ln>
+                <a:solidFill>
+                  <a:srgbClr val="00B050"/>
+                </a:solidFill>
+                <a:effectLst/>
+                <a:latin typeface="Arial" panose="020B0604020202020204" pitchFamily="34" charset="0"/>
+              </a:rPr>
+              <a:t>Auth::user() </a:t>
+            </a:r>
+            <a:r>
+              <a:rPr kumimoji="0" lang="en-US" altLang="en-US" sz="1300" b="0" i="0" u="none" strike="noStrike" cap="none" normalizeH="0" baseline="0">
+                <a:ln>
+                  <a:noFill/>
+                </a:ln>
+                <a:solidFill>
+                  <a:schemeClr val="tx1"/>
+                </a:solidFill>
+                <a:effectLst/>
+                <a:latin typeface="Arial" panose="020B0604020202020204" pitchFamily="34" charset="0"/>
+              </a:rPr>
+              <a:t>və </a:t>
+            </a:r>
+            <a:r>
+              <a:rPr kumimoji="0" lang="en-US" altLang="en-US" sz="1300" b="1" i="0" u="none" strike="noStrike" cap="none" normalizeH="0" baseline="0">
+                <a:ln>
+                  <a:noFill/>
+                </a:ln>
+                <a:solidFill>
+                  <a:srgbClr val="0070C0"/>
+                </a:solidFill>
+                <a:effectLst/>
+                <a:latin typeface="Arial" panose="020B0604020202020204" pitchFamily="34" charset="0"/>
+              </a:rPr>
+              <a:t>auth()-&gt;user() </a:t>
+            </a:r>
+            <a:r>
+              <a:rPr kumimoji="0" lang="en-US" altLang="en-US" sz="1300" b="0" i="0" u="none" strike="noStrike" cap="none" normalizeH="0" baseline="0">
+                <a:ln>
+                  <a:noFill/>
+                </a:ln>
+                <a:solidFill>
+                  <a:schemeClr val="tx1"/>
+                </a:solidFill>
+                <a:effectLst/>
+                <a:latin typeface="Arial" panose="020B0604020202020204" pitchFamily="34" charset="0"/>
+              </a:rPr>
+              <a:t>nə edir?</a:t>
+            </a:r>
+            <a:endParaRPr kumimoji="0" lang="az-Latn-AZ" altLang="en-US" sz="1300" b="0" i="0" u="none" strike="noStrike" cap="none" normalizeH="0" baseline="0">
+              <a:ln>
+                <a:noFill/>
+              </a:ln>
+              <a:solidFill>
+                <a:schemeClr val="tx1"/>
+              </a:solidFill>
+              <a:effectLst/>
+              <a:latin typeface="Arial" panose="020B0604020202020204" pitchFamily="34" charset="0"/>
+            </a:endParaRPr>
+          </a:p>
+          <a:p>
+            <a:pPr>
+              <a:lnSpc>
+                <a:spcPct val="150000"/>
+              </a:lnSpc>
+              <a:buNone/>
+            </a:pPr>
+            <a:endParaRPr kumimoji="0" lang="en-US" altLang="en-US" sz="1300" b="0" i="0" u="none" strike="noStrike" cap="none" normalizeH="0" baseline="0">
+              <a:ln>
+                <a:noFill/>
+              </a:ln>
+              <a:solidFill>
+                <a:schemeClr val="tx1"/>
+              </a:solidFill>
+              <a:effectLst/>
+              <a:latin typeface="Arial" panose="020B0604020202020204" pitchFamily="34" charset="0"/>
+            </a:endParaRPr>
+          </a:p>
+          <a:p>
+            <a:pPr>
+              <a:lnSpc>
+                <a:spcPct val="150000"/>
+              </a:lnSpc>
+              <a:buNone/>
+            </a:pPr>
+            <a:r>
+              <a:rPr kumimoji="0" lang="en-US" altLang="en-US" sz="1300" b="0" i="0" u="none" strike="noStrike" cap="none" normalizeH="0" baseline="0">
+                <a:ln>
+                  <a:noFill/>
+                </a:ln>
+                <a:solidFill>
+                  <a:schemeClr val="tx1"/>
+                </a:solidFill>
+                <a:effectLst/>
+                <a:latin typeface="Arial" panose="020B0604020202020204" pitchFamily="34" charset="0"/>
+              </a:rPr>
+              <a:t>Hər ikisi eynidir və Laravel-in Auth facade-</a:t>
+            </a:r>
+            <a:r>
+              <a:rPr kumimoji="0" lang="az-Latn-AZ" altLang="en-US" sz="1300" b="0" i="0" u="none" strike="noStrike" cap="none" normalizeH="0" baseline="0">
+                <a:ln>
+                  <a:noFill/>
+                </a:ln>
+                <a:solidFill>
+                  <a:schemeClr val="tx1"/>
+                </a:solidFill>
+                <a:effectLst/>
+                <a:latin typeface="Arial" panose="020B0604020202020204" pitchFamily="34" charset="0"/>
+              </a:rPr>
+              <a:t>ı</a:t>
+            </a:r>
+            <a:r>
+              <a:rPr kumimoji="0" lang="en-US" altLang="en-US" sz="1300" b="0" i="0" u="none" strike="noStrike" cap="none" normalizeH="0" baseline="0">
+                <a:ln>
+                  <a:noFill/>
+                </a:ln>
+                <a:solidFill>
+                  <a:schemeClr val="tx1"/>
+                </a:solidFill>
+                <a:effectLst/>
+                <a:latin typeface="Arial" panose="020B0604020202020204" pitchFamily="34" charset="0"/>
+              </a:rPr>
+              <a:t> vasitəsilə </a:t>
+            </a:r>
+            <a:endParaRPr kumimoji="0" lang="az-Latn-AZ" altLang="en-US" sz="1300" b="0" i="0" u="none" strike="noStrike" cap="none" normalizeH="0" baseline="0">
+              <a:ln>
+                <a:noFill/>
+              </a:ln>
+              <a:solidFill>
+                <a:schemeClr val="tx1"/>
+              </a:solidFill>
+              <a:effectLst/>
+              <a:latin typeface="Arial" panose="020B0604020202020204" pitchFamily="34" charset="0"/>
+            </a:endParaRPr>
+          </a:p>
+          <a:p>
+            <a:pPr>
+              <a:lnSpc>
+                <a:spcPct val="150000"/>
+              </a:lnSpc>
+              <a:buNone/>
+            </a:pPr>
+            <a:r>
+              <a:rPr kumimoji="0" lang="en-US" altLang="en-US" sz="1300" b="0" i="0" u="none" strike="noStrike" cap="none" normalizeH="0" baseline="0">
+                <a:ln>
+                  <a:noFill/>
+                </a:ln>
+                <a:solidFill>
+                  <a:schemeClr val="tx1"/>
+                </a:solidFill>
+                <a:effectLst/>
+                <a:latin typeface="Arial" panose="020B0604020202020204" pitchFamily="34" charset="0"/>
+              </a:rPr>
+              <a:t>hal-hazırda giriş etmiş istifadəçi obyektini </a:t>
+            </a:r>
+            <a:endParaRPr kumimoji="0" lang="az-Latn-AZ" altLang="en-US" sz="1300" b="0" i="0" u="none" strike="noStrike" cap="none" normalizeH="0" baseline="0">
+              <a:ln>
+                <a:noFill/>
+              </a:ln>
+              <a:solidFill>
+                <a:schemeClr val="tx1"/>
+              </a:solidFill>
+              <a:effectLst/>
+              <a:latin typeface="Arial" panose="020B0604020202020204" pitchFamily="34" charset="0"/>
+            </a:endParaRPr>
+          </a:p>
+          <a:p>
+            <a:pPr>
+              <a:lnSpc>
+                <a:spcPct val="150000"/>
+              </a:lnSpc>
+              <a:buNone/>
+            </a:pPr>
+            <a:r>
+              <a:rPr kumimoji="0" lang="en-US" altLang="en-US" sz="1300" b="0" i="0" u="none" strike="noStrike" cap="none" normalizeH="0" baseline="0">
+                <a:ln>
+                  <a:noFill/>
+                </a:ln>
+                <a:solidFill>
+                  <a:schemeClr val="tx1"/>
+                </a:solidFill>
+                <a:effectLst/>
+                <a:latin typeface="Arial" panose="020B0604020202020204" pitchFamily="34" charset="0"/>
+              </a:rPr>
+              <a:t>(</a:t>
+            </a:r>
+            <a:r>
+              <a:rPr kumimoji="0" lang="en-US" altLang="en-US" sz="1300" b="1" i="0" u="none" strike="noStrike" cap="none" normalizeH="0" baseline="0">
+                <a:ln>
+                  <a:noFill/>
+                </a:ln>
+                <a:solidFill>
+                  <a:schemeClr val="tx1"/>
+                </a:solidFill>
+                <a:effectLst/>
+                <a:latin typeface="Arial" panose="020B0604020202020204" pitchFamily="34" charset="0"/>
+              </a:rPr>
+              <a:t>App\Models\User</a:t>
+            </a:r>
+            <a:r>
+              <a:rPr kumimoji="0" lang="en-US" altLang="en-US" sz="1300" b="0" i="0" u="none" strike="noStrike" cap="none" normalizeH="0" baseline="0">
+                <a:ln>
+                  <a:noFill/>
+                </a:ln>
+                <a:solidFill>
+                  <a:schemeClr val="tx1"/>
+                </a:solidFill>
+                <a:effectLst/>
+                <a:latin typeface="Arial" panose="020B0604020202020204" pitchFamily="34" charset="0"/>
+              </a:rPr>
+              <a:t>) geri qaytarır.</a:t>
+            </a:r>
+          </a:p>
+          <a:p>
+            <a:pPr>
+              <a:lnSpc>
+                <a:spcPct val="150000"/>
+              </a:lnSpc>
+              <a:buNone/>
+            </a:pPr>
+            <a:endParaRPr kumimoji="0" lang="en-US" altLang="en-US" sz="1300" b="0" i="0" u="none" strike="noStrike" cap="none" normalizeH="0" baseline="0">
+              <a:ln>
+                <a:noFill/>
+              </a:ln>
+              <a:solidFill>
+                <a:schemeClr val="tx1"/>
+              </a:solidFill>
+              <a:effectLst/>
+              <a:latin typeface="Arial" panose="020B0604020202020204" pitchFamily="34" charset="0"/>
+            </a:endParaRPr>
+          </a:p>
+          <a:p>
+            <a:pPr>
+              <a:lnSpc>
+                <a:spcPct val="150000"/>
+              </a:lnSpc>
+              <a:buNone/>
+            </a:pPr>
+            <a:endParaRPr kumimoji="0" lang="en-US" altLang="en-US" sz="1300" b="0" i="0" u="none" strike="noStrike" cap="none" normalizeH="0" baseline="0">
+              <a:ln>
+                <a:noFill/>
+              </a:ln>
+              <a:solidFill>
+                <a:schemeClr val="tx1"/>
+              </a:solidFill>
+              <a:effectLst/>
+              <a:latin typeface="Arial" panose="020B0604020202020204" pitchFamily="34" charset="0"/>
+            </a:endParaRPr>
+          </a:p>
+        </p:txBody>
+      </p:sp>
+      <p:pic>
+        <p:nvPicPr>
+          <p:cNvPr id="4" name="Picture 3">
+            <a:extLst>
+              <a:ext uri="{FF2B5EF4-FFF2-40B4-BE49-F238E27FC236}">
+                <a16:creationId xmlns:a16="http://schemas.microsoft.com/office/drawing/2014/main" id="{4EE98F7A-1646-72E6-0399-C0405EFD2022}"/>
+              </a:ext>
+            </a:extLst>
+          </p:cNvPr>
+          <p:cNvPicPr>
+            <a:picLocks noChangeAspect="1"/>
+          </p:cNvPicPr>
+          <p:nvPr/>
+        </p:nvPicPr>
+        <p:blipFill>
+          <a:blip r:embed="rId2"/>
+          <a:stretch>
+            <a:fillRect/>
+          </a:stretch>
+        </p:blipFill>
+        <p:spPr>
+          <a:xfrm>
+            <a:off x="4941455" y="1977526"/>
+            <a:ext cx="7250545" cy="4880474"/>
+          </a:xfrm>
+          <a:prstGeom prst="rect">
+            <a:avLst/>
+          </a:prstGeom>
+        </p:spPr>
+      </p:pic>
+      <p:pic>
+        <p:nvPicPr>
+          <p:cNvPr id="6" name="Picture 5">
+            <a:extLst>
+              <a:ext uri="{FF2B5EF4-FFF2-40B4-BE49-F238E27FC236}">
+                <a16:creationId xmlns:a16="http://schemas.microsoft.com/office/drawing/2014/main" id="{5277B782-4BA0-88B9-6149-85F9BBF08459}"/>
+              </a:ext>
+            </a:extLst>
+          </p:cNvPr>
+          <p:cNvPicPr>
+            <a:picLocks noChangeAspect="1"/>
+          </p:cNvPicPr>
+          <p:nvPr/>
+        </p:nvPicPr>
+        <p:blipFill>
+          <a:blip r:embed="rId3"/>
+          <a:stretch>
+            <a:fillRect/>
+          </a:stretch>
+        </p:blipFill>
+        <p:spPr>
+          <a:xfrm>
+            <a:off x="-1" y="4991698"/>
+            <a:ext cx="4572638" cy="762106"/>
+          </a:xfrm>
+          <a:prstGeom prst="rect">
+            <a:avLst/>
+          </a:prstGeom>
+        </p:spPr>
+      </p:pic>
     </p:spTree>
     <p:extLst>
       <p:ext uri="{BB962C8B-B14F-4D97-AF65-F5344CB8AC3E}">
@@ -3435,7 +3937,7 @@
         <p:spPr>
           <a:xfrm>
             <a:off x="217714" y="255046"/>
-            <a:ext cx="11756571" cy="355354"/>
+            <a:ext cx="11756571" cy="4256422"/>
           </a:xfrm>
           <a:prstGeom prst="rect">
             <a:avLst/>
@@ -3454,6 +3956,19 @@
               </a:lnSpc>
               <a:buNone/>
             </a:pPr>
+            <a:r>
+              <a:rPr kumimoji="0" lang="en-US" altLang="en-US" sz="1300" b="1" i="0" u="none" strike="noStrike" cap="none" normalizeH="0" baseline="0">
+                <a:ln>
+                  <a:noFill/>
+                </a:ln>
+                <a:solidFill>
+                  <a:schemeClr val="accent2"/>
+                </a:solidFill>
+                <a:effectLst/>
+                <a:latin typeface="Arial" panose="020B0604020202020204" pitchFamily="34" charset="0"/>
+              </a:rPr>
+              <a:t>Mühüm Qeyd</a:t>
+            </a:r>
             <a:r>
               <a:rPr kumimoji="0" lang="en-US" altLang="en-US" sz="1300" b="0" i="0" u="none" strike="noStrike" cap="none" normalizeH="0" baseline="0">
                 <a:ln>
@@ -3465,11 +3980,1325 @@
                 <a:effectLst/>
                 <a:latin typeface="Arial" panose="020B0604020202020204" pitchFamily="34" charset="0"/>
               </a:rPr>
-              <a:t>.</a:t>
-            </a:r>
-          </a:p>
-        </p:txBody>
-      </p:sp>
+              <a:t>:</a:t>
+            </a:r>
+            <a:r>
+              <a:rPr kumimoji="0" lang="az-Latn-AZ" altLang="en-US" sz="1300" b="0" i="0" u="none" strike="noStrike" cap="none" normalizeH="0" baseline="0">
+                <a:ln>
+                  <a:noFill/>
+                </a:ln>
+                <a:solidFill>
+                  <a:schemeClr val="tx1"/>
+                </a:solidFill>
+                <a:effectLst/>
+                <a:latin typeface="Arial" panose="020B0604020202020204" pitchFamily="34" charset="0"/>
+              </a:rPr>
+              <a:t> </a:t>
+            </a:r>
+            <a:r>
+              <a:rPr kumimoji="0" lang="en-US" altLang="en-US" sz="1300" b="0" i="0" u="none" strike="noStrike" cap="none" normalizeH="0" baseline="0">
+                <a:ln>
+                  <a:noFill/>
+                </a:ln>
+                <a:solidFill>
+                  <a:schemeClr val="tx1"/>
+                </a:solidFill>
+                <a:effectLst/>
+                <a:latin typeface="Arial" panose="020B0604020202020204" pitchFamily="34" charset="0"/>
+              </a:rPr>
+              <a:t>Bu route-u qorumaq lazımdır, əks halda login olmayan istifadəçi üçün səhv alarsan.</a:t>
+            </a:r>
+            <a:r>
+              <a:rPr kumimoji="0" lang="az-Latn-AZ" altLang="en-US" sz="1300" b="0" i="0" u="none" strike="noStrike" cap="none" normalizeH="0" baseline="0">
+                <a:ln>
+                  <a:noFill/>
+                </a:ln>
+                <a:solidFill>
+                  <a:schemeClr val="tx1"/>
+                </a:solidFill>
+                <a:effectLst/>
+                <a:latin typeface="Arial" panose="020B0604020202020204" pitchFamily="34" charset="0"/>
+              </a:rPr>
+              <a:t> </a:t>
+            </a:r>
+          </a:p>
+          <a:p>
+            <a:pPr>
+              <a:lnSpc>
+                <a:spcPct val="150000"/>
+              </a:lnSpc>
+              <a:buNone/>
+            </a:pPr>
+            <a:endParaRPr lang="az-Latn-AZ" altLang="en-US" sz="1300">
+              <a:latin typeface="Arial" panose="020B0604020202020204" pitchFamily="34" charset="0"/>
+            </a:endParaRPr>
+          </a:p>
+          <a:p>
+            <a:pPr>
+              <a:lnSpc>
+                <a:spcPct val="150000"/>
+              </a:lnSpc>
+              <a:buNone/>
+            </a:pPr>
+            <a:r>
+              <a:rPr kumimoji="0" lang="en-US" altLang="en-US" sz="1300" b="0" i="0" u="none" strike="noStrike" cap="none" normalizeH="0" baseline="0">
+                <a:ln>
+                  <a:noFill/>
+                </a:ln>
+                <a:solidFill>
+                  <a:schemeClr val="tx1"/>
+                </a:solidFill>
+                <a:effectLst/>
+                <a:latin typeface="Arial" panose="020B0604020202020204" pitchFamily="34" charset="0"/>
+              </a:rPr>
+              <a:t>Buna görə</a:t>
+            </a:r>
+            <a:r>
+              <a:rPr kumimoji="0" lang="az-Latn-AZ" altLang="en-US" sz="1300" b="0" i="0" u="none" strike="noStrike" cap="none" normalizeH="0" baseline="0">
+                <a:ln>
+                  <a:noFill/>
+                </a:ln>
+                <a:solidFill>
+                  <a:schemeClr val="tx1"/>
+                </a:solidFill>
+                <a:effectLst/>
+                <a:latin typeface="Arial" panose="020B0604020202020204" pitchFamily="34" charset="0"/>
+              </a:rPr>
+              <a:t> də</a:t>
+            </a:r>
+            <a:r>
+              <a:rPr kumimoji="0" lang="en-US" altLang="en-US" sz="1300" b="0" i="0" u="none" strike="noStrike" cap="none" normalizeH="0" baseline="0">
+                <a:ln>
+                  <a:noFill/>
+                </a:ln>
+                <a:solidFill>
+                  <a:schemeClr val="tx1"/>
+                </a:solidFill>
+                <a:effectLst/>
+                <a:latin typeface="Arial" panose="020B0604020202020204" pitchFamily="34" charset="0"/>
+              </a:rPr>
+              <a:t>,</a:t>
+            </a:r>
+            <a:r>
+              <a:rPr kumimoji="0" lang="az-Latn-AZ" altLang="en-US" sz="1300" b="0" i="0" u="none" strike="noStrike" cap="none" normalizeH="0" baseline="0">
+                <a:ln>
+                  <a:noFill/>
+                </a:ln>
+                <a:solidFill>
+                  <a:schemeClr val="tx1"/>
+                </a:solidFill>
+                <a:effectLst/>
+                <a:latin typeface="Arial" panose="020B0604020202020204" pitchFamily="34" charset="0"/>
+              </a:rPr>
+              <a:t> hər ehtimala qarşılıq</a:t>
+            </a:r>
+            <a:r>
+              <a:rPr kumimoji="0" lang="en-US" altLang="en-US" sz="1300" b="0" i="0" u="none" strike="noStrike" cap="none" normalizeH="0" baseline="0">
+                <a:ln>
+                  <a:noFill/>
+                </a:ln>
+                <a:solidFill>
+                  <a:schemeClr val="tx1"/>
+                </a:solidFill>
+                <a:effectLst/>
+                <a:latin typeface="Arial" panose="020B0604020202020204" pitchFamily="34" charset="0"/>
+              </a:rPr>
+              <a:t> </a:t>
+            </a:r>
+            <a:r>
+              <a:rPr kumimoji="0" lang="en-US" altLang="en-US" sz="1300" b="1" i="0" u="none" strike="noStrike" cap="none" normalizeH="0" baseline="0">
+                <a:ln>
+                  <a:noFill/>
+                </a:ln>
+                <a:solidFill>
+                  <a:schemeClr val="tx1"/>
+                </a:solidFill>
+                <a:effectLst/>
+                <a:latin typeface="Arial" panose="020B0604020202020204" pitchFamily="34" charset="0"/>
+              </a:rPr>
+              <a:t>middleware</a:t>
+            </a:r>
+            <a:r>
+              <a:rPr kumimoji="0" lang="en-US" altLang="en-US" sz="1300" b="0" i="0" u="none" strike="noStrike" cap="none" normalizeH="0" baseline="0">
+                <a:ln>
+                  <a:noFill/>
+                </a:ln>
+                <a:solidFill>
+                  <a:schemeClr val="tx1"/>
+                </a:solidFill>
+                <a:effectLst/>
+                <a:latin typeface="Arial" panose="020B0604020202020204" pitchFamily="34" charset="0"/>
+              </a:rPr>
+              <a:t> əlavə etmək mütləqdir:</a:t>
+            </a:r>
+            <a:endParaRPr kumimoji="0" lang="az-Latn-AZ" altLang="en-US" sz="1300" b="0" i="0" u="none" strike="noStrike" cap="none" normalizeH="0" baseline="0">
+              <a:ln>
+                <a:noFill/>
+              </a:ln>
+              <a:solidFill>
+                <a:schemeClr val="tx1"/>
+              </a:solidFill>
+              <a:effectLst/>
+              <a:latin typeface="Arial" panose="020B0604020202020204" pitchFamily="34" charset="0"/>
+            </a:endParaRPr>
+          </a:p>
+          <a:p>
+            <a:pPr>
+              <a:lnSpc>
+                <a:spcPct val="150000"/>
+              </a:lnSpc>
+              <a:buNone/>
+            </a:pPr>
+            <a:endParaRPr lang="az-Latn-AZ" altLang="en-US" sz="1300">
+              <a:latin typeface="Arial" panose="020B0604020202020204" pitchFamily="34" charset="0"/>
+            </a:endParaRPr>
+          </a:p>
+          <a:p>
+            <a:pPr>
+              <a:lnSpc>
+                <a:spcPct val="150000"/>
+              </a:lnSpc>
+              <a:buNone/>
+            </a:pPr>
+            <a:endParaRPr kumimoji="0" lang="az-Latn-AZ" altLang="en-US" sz="1300" b="0" i="0" u="none" strike="noStrike" cap="none" normalizeH="0" baseline="0">
+              <a:ln>
+                <a:noFill/>
+              </a:ln>
+              <a:solidFill>
+                <a:schemeClr val="tx1"/>
+              </a:solidFill>
+              <a:effectLst/>
+              <a:latin typeface="Arial" panose="020B0604020202020204" pitchFamily="34" charset="0"/>
+            </a:endParaRPr>
+          </a:p>
+          <a:p>
+            <a:pPr>
+              <a:lnSpc>
+                <a:spcPct val="150000"/>
+              </a:lnSpc>
+              <a:buNone/>
+            </a:pPr>
+            <a:endParaRPr lang="az-Latn-AZ" altLang="en-US" sz="1300">
+              <a:latin typeface="Arial" panose="020B0604020202020204" pitchFamily="34" charset="0"/>
+            </a:endParaRPr>
+          </a:p>
+          <a:p>
+            <a:pPr>
+              <a:lnSpc>
+                <a:spcPct val="150000"/>
+              </a:lnSpc>
+              <a:buNone/>
+            </a:pPr>
+            <a:endParaRPr kumimoji="0" lang="az-Latn-AZ" altLang="en-US" sz="1300" b="0" i="0" u="none" strike="noStrike" cap="none" normalizeH="0" baseline="0">
+              <a:ln>
+                <a:noFill/>
+              </a:ln>
+              <a:solidFill>
+                <a:schemeClr val="tx1"/>
+              </a:solidFill>
+              <a:effectLst/>
+              <a:latin typeface="Arial" panose="020B0604020202020204" pitchFamily="34" charset="0"/>
+            </a:endParaRPr>
+          </a:p>
+          <a:p>
+            <a:pPr>
+              <a:lnSpc>
+                <a:spcPct val="150000"/>
+              </a:lnSpc>
+              <a:buNone/>
+            </a:pPr>
+            <a:endParaRPr lang="az-Latn-AZ" altLang="en-US" sz="1300">
+              <a:latin typeface="Arial" panose="020B0604020202020204" pitchFamily="34" charset="0"/>
+            </a:endParaRPr>
+          </a:p>
+          <a:p>
+            <a:pPr>
+              <a:lnSpc>
+                <a:spcPct val="150000"/>
+              </a:lnSpc>
+              <a:buNone/>
+            </a:pPr>
+            <a:r>
+              <a:rPr kumimoji="0" lang="en-US" altLang="en-US" sz="1300" b="1" i="0" u="none" strike="noStrike" cap="none" normalizeH="0" baseline="0">
+                <a:ln>
+                  <a:noFill/>
+                </a:ln>
+                <a:solidFill>
+                  <a:srgbClr val="FF0000"/>
+                </a:solidFill>
+                <a:effectLst/>
+                <a:latin typeface="Arial" panose="020B0604020202020204" pitchFamily="34" charset="0"/>
+              </a:rPr>
+              <a:t>auth middleware </a:t>
+            </a:r>
+            <a:r>
+              <a:rPr kumimoji="0" lang="en-US" altLang="en-US" sz="1300" b="0" i="0" u="none" strike="noStrike" cap="none" normalizeH="0" baseline="0">
+                <a:ln>
+                  <a:noFill/>
+                </a:ln>
+                <a:solidFill>
+                  <a:schemeClr val="tx1"/>
+                </a:solidFill>
+                <a:effectLst/>
+                <a:latin typeface="Arial" panose="020B0604020202020204" pitchFamily="34" charset="0"/>
+              </a:rPr>
+              <a:t>nə edir?</a:t>
+            </a:r>
+          </a:p>
+          <a:p>
+            <a:pPr marL="742950" lvl="1" indent="-285750">
+              <a:lnSpc>
+                <a:spcPct val="150000"/>
+              </a:lnSpc>
+              <a:buFont typeface="Arial" panose="020B0604020202020204" pitchFamily="34" charset="0"/>
+              <a:buChar char="•"/>
+            </a:pPr>
+            <a:r>
+              <a:rPr kumimoji="0" lang="en-US" altLang="en-US" sz="1300" b="0" i="0" u="none" strike="noStrike" cap="none" normalizeH="0" baseline="0">
+                <a:ln>
+                  <a:noFill/>
+                </a:ln>
+                <a:solidFill>
+                  <a:schemeClr val="tx1"/>
+                </a:solidFill>
+                <a:effectLst/>
+                <a:latin typeface="Arial" panose="020B0604020202020204" pitchFamily="34" charset="0"/>
+              </a:rPr>
+              <a:t>Bu </a:t>
+            </a:r>
+            <a:r>
+              <a:rPr kumimoji="0" lang="en-US" altLang="en-US" sz="1300" b="1" i="0" u="none" strike="noStrike" cap="none" normalizeH="0" baseline="0">
+                <a:ln>
+                  <a:noFill/>
+                </a:ln>
+                <a:solidFill>
+                  <a:schemeClr val="tx1"/>
+                </a:solidFill>
+                <a:effectLst/>
+                <a:latin typeface="Arial" panose="020B0604020202020204" pitchFamily="34" charset="0"/>
+              </a:rPr>
+              <a:t>middleware</a:t>
+            </a:r>
+            <a:r>
+              <a:rPr kumimoji="0" lang="en-US" altLang="en-US" sz="1300" b="0" i="0" u="none" strike="noStrike" cap="none" normalizeH="0" baseline="0">
+                <a:ln>
+                  <a:noFill/>
+                </a:ln>
+                <a:solidFill>
+                  <a:schemeClr val="tx1"/>
+                </a:solidFill>
+                <a:effectLst/>
+                <a:latin typeface="Arial" panose="020B0604020202020204" pitchFamily="34" charset="0"/>
+              </a:rPr>
+              <a:t> yoxlayır ki, istifadəçi </a:t>
+            </a:r>
+            <a:r>
+              <a:rPr kumimoji="0" lang="en-US" altLang="en-US" sz="1300" b="1" i="0" u="none" strike="noStrike" cap="none" normalizeH="0" baseline="0">
+                <a:ln>
+                  <a:noFill/>
+                </a:ln>
+                <a:solidFill>
+                  <a:schemeClr val="tx1"/>
+                </a:solidFill>
+                <a:effectLst/>
+                <a:latin typeface="Arial" panose="020B0604020202020204" pitchFamily="34" charset="0"/>
+              </a:rPr>
+              <a:t>login</a:t>
+            </a:r>
+            <a:r>
+              <a:rPr kumimoji="0" lang="en-US" altLang="en-US" sz="1300" b="0" i="0" u="none" strike="noStrike" cap="none" normalizeH="0" baseline="0">
+                <a:ln>
+                  <a:noFill/>
+                </a:ln>
+                <a:solidFill>
+                  <a:schemeClr val="tx1"/>
+                </a:solidFill>
+                <a:effectLst/>
+                <a:latin typeface="Arial" panose="020B0604020202020204" pitchFamily="34" charset="0"/>
+              </a:rPr>
+              <a:t> olub, ya yox. Əgər yoxdursa, onu </a:t>
+            </a:r>
+            <a:r>
+              <a:rPr kumimoji="0" lang="en-US" altLang="en-US" sz="1300" b="1" i="0" u="none" strike="noStrike" cap="none" normalizeH="0" baseline="0">
+                <a:ln>
+                  <a:noFill/>
+                </a:ln>
+                <a:solidFill>
+                  <a:schemeClr val="tx1"/>
+                </a:solidFill>
+                <a:effectLst/>
+                <a:latin typeface="Arial" panose="020B0604020202020204" pitchFamily="34" charset="0"/>
+              </a:rPr>
+              <a:t>/login </a:t>
+            </a:r>
+            <a:r>
+              <a:rPr kumimoji="0" lang="en-US" altLang="en-US" sz="1300" b="0" i="0" u="none" strike="noStrike" cap="none" normalizeH="0" baseline="0">
+                <a:ln>
+                  <a:noFill/>
+                </a:ln>
+                <a:solidFill>
+                  <a:schemeClr val="tx1"/>
+                </a:solidFill>
+                <a:effectLst/>
+                <a:latin typeface="Arial" panose="020B0604020202020204" pitchFamily="34" charset="0"/>
+              </a:rPr>
+              <a:t>səhifəsinə yönləndirir.</a:t>
+            </a:r>
+            <a:endParaRPr kumimoji="0" lang="az-Latn-AZ" altLang="en-US" sz="1300" b="0" i="0" u="none" strike="noStrike" cap="none" normalizeH="0" baseline="0">
+              <a:ln>
+                <a:noFill/>
+              </a:ln>
+              <a:solidFill>
+                <a:schemeClr val="tx1"/>
+              </a:solidFill>
+              <a:effectLst/>
+              <a:latin typeface="Arial" panose="020B0604020202020204" pitchFamily="34" charset="0"/>
+            </a:endParaRPr>
+          </a:p>
+          <a:p>
+            <a:pPr>
+              <a:lnSpc>
+                <a:spcPct val="150000"/>
+              </a:lnSpc>
+              <a:buNone/>
+            </a:pPr>
+            <a:endParaRPr lang="az-Latn-AZ" altLang="en-US" sz="1300">
+              <a:latin typeface="Arial" panose="020B0604020202020204" pitchFamily="34" charset="0"/>
+            </a:endParaRPr>
+          </a:p>
+          <a:p>
+            <a:pPr>
+              <a:lnSpc>
+                <a:spcPct val="150000"/>
+              </a:lnSpc>
+              <a:buNone/>
+            </a:pPr>
+            <a:endParaRPr lang="az-Latn-AZ" altLang="en-US" sz="1300">
+              <a:latin typeface="Arial" panose="020B0604020202020204" pitchFamily="34" charset="0"/>
+            </a:endParaRPr>
+          </a:p>
+          <a:p>
+            <a:pPr>
+              <a:lnSpc>
+                <a:spcPct val="150000"/>
+              </a:lnSpc>
+              <a:buNone/>
+            </a:pPr>
+            <a:r>
+              <a:rPr kumimoji="0" lang="az-Latn-AZ" altLang="en-US" sz="1300" b="1" i="0" u="none" strike="noStrike" cap="none" normalizeH="0" baseline="0">
+                <a:ln>
+                  <a:noFill/>
+                </a:ln>
+                <a:solidFill>
+                  <a:schemeClr val="tx1"/>
+                </a:solidFill>
+                <a:effectLst/>
+                <a:latin typeface="Arial" panose="020B0604020202020204" pitchFamily="34" charset="0"/>
+              </a:rPr>
+              <a:t>Xülasə</a:t>
+            </a:r>
+            <a:r>
+              <a:rPr kumimoji="0" lang="az-Latn-AZ" altLang="en-US" sz="1300" b="0" i="0" u="none" strike="noStrike" cap="none" normalizeH="0" baseline="0">
+                <a:ln>
+                  <a:noFill/>
+                </a:ln>
+                <a:solidFill>
+                  <a:schemeClr val="tx1"/>
+                </a:solidFill>
+                <a:effectLst/>
+                <a:latin typeface="Arial" panose="020B0604020202020204" pitchFamily="34" charset="0"/>
+              </a:rPr>
+              <a:t>:</a:t>
+            </a:r>
+          </a:p>
+          <a:p>
+            <a:pPr>
+              <a:lnSpc>
+                <a:spcPct val="150000"/>
+              </a:lnSpc>
+              <a:buNone/>
+            </a:pPr>
+            <a:endParaRPr kumimoji="0" lang="en-US" altLang="en-US" sz="1300" b="0" i="0" u="none" strike="noStrike" cap="none" normalizeH="0" baseline="0">
+              <a:ln>
+                <a:noFill/>
+              </a:ln>
+              <a:solidFill>
+                <a:schemeClr val="tx1"/>
+              </a:solidFill>
+              <a:effectLst/>
+              <a:latin typeface="Arial" panose="020B0604020202020204" pitchFamily="34" charset="0"/>
+            </a:endParaRPr>
+          </a:p>
+        </p:txBody>
+      </p:sp>
+      <p:pic>
+        <p:nvPicPr>
+          <p:cNvPr id="4" name="Picture 3">
+            <a:extLst>
+              <a:ext uri="{FF2B5EF4-FFF2-40B4-BE49-F238E27FC236}">
+                <a16:creationId xmlns:a16="http://schemas.microsoft.com/office/drawing/2014/main" id="{2B7A6E95-99C2-3823-0119-1BF356B12BDF}"/>
+              </a:ext>
+            </a:extLst>
+          </p:cNvPr>
+          <p:cNvPicPr>
+            <a:picLocks noChangeAspect="1"/>
+          </p:cNvPicPr>
+          <p:nvPr/>
+        </p:nvPicPr>
+        <p:blipFill>
+          <a:blip r:embed="rId2"/>
+          <a:stretch>
+            <a:fillRect/>
+          </a:stretch>
+        </p:blipFill>
+        <p:spPr>
+          <a:xfrm>
+            <a:off x="0" y="1280612"/>
+            <a:ext cx="3715268" cy="971686"/>
+          </a:xfrm>
+          <a:prstGeom prst="rect">
+            <a:avLst/>
+          </a:prstGeom>
+        </p:spPr>
+      </p:pic>
+      <p:graphicFrame>
+        <p:nvGraphicFramePr>
+          <p:cNvPr id="5" name="Table 4">
+            <a:extLst>
+              <a:ext uri="{FF2B5EF4-FFF2-40B4-BE49-F238E27FC236}">
+                <a16:creationId xmlns:a16="http://schemas.microsoft.com/office/drawing/2014/main" id="{1A3DBE1E-DAF0-09B1-52DC-FC6EFF35290E}"/>
+              </a:ext>
+            </a:extLst>
+          </p:cNvPr>
+          <p:cNvGraphicFramePr>
+            <a:graphicFrameLocks noGrp="1"/>
+          </p:cNvGraphicFramePr>
+          <p:nvPr>
+            <p:extLst>
+              <p:ext uri="{D42A27DB-BD31-4B8C-83A1-F6EECF244321}">
+                <p14:modId xmlns:p14="http://schemas.microsoft.com/office/powerpoint/2010/main" val="1964721087"/>
+              </p:ext>
+            </p:extLst>
+          </p:nvPr>
+        </p:nvGraphicFramePr>
+        <p:xfrm>
+          <a:off x="217713" y="4302593"/>
+          <a:ext cx="10524178" cy="2421480"/>
+        </p:xfrm>
+        <a:graphic>
+          <a:graphicData uri="http://schemas.openxmlformats.org/drawingml/2006/table">
+            <a:tbl>
+              <a:tblPr/>
+              <a:tblGrid>
+                <a:gridCol w="2730912">
+                  <a:extLst>
+                    <a:ext uri="{9D8B030D-6E8A-4147-A177-3AD203B41FA5}">
+                      <a16:colId xmlns:a16="http://schemas.microsoft.com/office/drawing/2014/main" val="2231372380"/>
+                    </a:ext>
+                  </a:extLst>
+                </a:gridCol>
+                <a:gridCol w="7793266">
+                  <a:extLst>
+                    <a:ext uri="{9D8B030D-6E8A-4147-A177-3AD203B41FA5}">
+                      <a16:colId xmlns:a16="http://schemas.microsoft.com/office/drawing/2014/main" val="4117873350"/>
+                    </a:ext>
+                  </a:extLst>
+                </a:gridCol>
+              </a:tblGrid>
+              <a:tr h="403580">
+                <a:tc>
+                  <a:txBody>
+                    <a:bodyPr/>
+                    <a:lstStyle/>
+                    <a:p>
+                      <a:r>
+                        <a:rPr lang="en-US" b="1"/>
+                        <a:t>İfadə</a:t>
+                      </a:r>
+                    </a:p>
+                  </a:txBody>
+                  <a:tcPr anchor="ctr">
+                    <a:lnL w="12700" cap="flat" cmpd="sng" algn="ctr">
+                      <a:solidFill>
+                        <a:schemeClr val="tx1"/>
+                      </a:solidFill>
+                      <a:prstDash val="solid"/>
+                      <a:round/>
+                      <a:headEnd type="none" w="med" len="med"/>
+                      <a:tailEnd type="none" w="med" len="med"/>
+                    </a:lnL>
+                    <a:lnR w="12700" cap="flat" cmpd="sng" algn="ctr">
+                      <a:solidFill>
+                        <a:schemeClr val="tx1"/>
+                      </a:solidFill>
+                      <a:prstDash val="solid"/>
+                      <a:round/>
+                      <a:headEnd type="none" w="med" len="med"/>
+                      <a:tailEnd type="none" w="med" len="med"/>
+                    </a:lnR>
+                    <a:lnT w="12700" cap="flat" cmpd="sng" algn="ctr">
+                      <a:solidFill>
+                        <a:schemeClr val="tx1"/>
+                      </a:solidFill>
+                      <a:prstDash val="solid"/>
+                      <a:round/>
+                      <a:headEnd type="none" w="med" len="med"/>
+                      <a:tailEnd type="none" w="med" len="med"/>
+                    </a:lnT>
+                    <a:lnB w="12700" cap="flat" cmpd="sng" algn="ctr">
+                      <a:solidFill>
+                        <a:schemeClr val="tx1"/>
+                      </a:solidFill>
+                      <a:prstDash val="solid"/>
+                      <a:round/>
+                      <a:headEnd type="none" w="med" len="med"/>
+                      <a:tailEnd type="none" w="med" len="med"/>
+                    </a:lnB>
+                    <a:solidFill>
+                      <a:schemeClr val="accent2"/>
+                    </a:solidFill>
+                  </a:tcPr>
+                </a:tc>
+                <a:tc>
+                  <a:txBody>
+                    <a:bodyPr/>
+                    <a:lstStyle/>
+                    <a:p>
+                      <a:r>
+                        <a:rPr lang="en-US" b="1"/>
+                        <a:t>Nə edir</a:t>
+                      </a:r>
+                    </a:p>
+                  </a:txBody>
+                  <a:tcPr anchor="ctr">
+                    <a:lnL w="12700" cap="flat" cmpd="sng" algn="ctr">
+                      <a:solidFill>
+                        <a:schemeClr val="tx1"/>
+                      </a:solidFill>
+                      <a:prstDash val="solid"/>
+                      <a:round/>
+                      <a:headEnd type="none" w="med" len="med"/>
+                      <a:tailEnd type="none" w="med" len="med"/>
+                    </a:lnL>
+                    <a:lnR w="12700" cap="flat" cmpd="sng" algn="ctr">
+                      <a:solidFill>
+                        <a:schemeClr val="tx1"/>
+                      </a:solidFill>
+                      <a:prstDash val="solid"/>
+                      <a:round/>
+                      <a:headEnd type="none" w="med" len="med"/>
+                      <a:tailEnd type="none" w="med" len="med"/>
+                    </a:lnR>
+                    <a:lnT w="12700" cap="flat" cmpd="sng" algn="ctr">
+                      <a:solidFill>
+                        <a:schemeClr val="tx1"/>
+                      </a:solidFill>
+                      <a:prstDash val="solid"/>
+                      <a:round/>
+                      <a:headEnd type="none" w="med" len="med"/>
+                      <a:tailEnd type="none" w="med" len="med"/>
+                    </a:lnT>
+                    <a:lnB w="12700" cap="flat" cmpd="sng" algn="ctr">
+                      <a:solidFill>
+                        <a:schemeClr val="tx1"/>
+                      </a:solidFill>
+                      <a:prstDash val="solid"/>
+                      <a:round/>
+                      <a:headEnd type="none" w="med" len="med"/>
+                      <a:tailEnd type="none" w="med" len="med"/>
+                    </a:lnB>
+                    <a:solidFill>
+                      <a:schemeClr val="accent2"/>
+                    </a:solidFill>
+                  </a:tcPr>
+                </a:tc>
+                <a:extLst>
+                  <a:ext uri="{0D108BD9-81ED-4DB2-BD59-A6C34878D82A}">
+                    <a16:rowId xmlns:a16="http://schemas.microsoft.com/office/drawing/2014/main" val="1514530500"/>
+                  </a:ext>
+                </a:extLst>
+              </a:tr>
+              <a:tr h="403580">
+                <a:tc>
+                  <a:txBody>
+                    <a:bodyPr/>
+                    <a:lstStyle/>
+                    <a:p>
+                      <a:r>
+                        <a:rPr lang="en-US" b="1">
+                          <a:solidFill>
+                            <a:srgbClr val="FF0000"/>
+                          </a:solidFill>
+                        </a:rPr>
+                        <a:t>Auth</a:t>
+                      </a:r>
+                      <a:r>
+                        <a:rPr lang="en-US" b="1">
+                          <a:solidFill>
+                            <a:schemeClr val="tx1"/>
+                          </a:solidFill>
+                        </a:rPr>
+                        <a:t>::</a:t>
+                      </a:r>
+                      <a:r>
+                        <a:rPr lang="en-US" b="1">
+                          <a:solidFill>
+                            <a:srgbClr val="FF0000"/>
+                          </a:solidFill>
+                        </a:rPr>
+                        <a:t>user()</a:t>
+                      </a:r>
+                    </a:p>
+                  </a:txBody>
+                  <a:tcPr anchor="ctr">
+                    <a:lnL w="12700" cap="flat" cmpd="sng" algn="ctr">
+                      <a:solidFill>
+                        <a:schemeClr val="tx1"/>
+                      </a:solidFill>
+                      <a:prstDash val="solid"/>
+                      <a:round/>
+                      <a:headEnd type="none" w="med" len="med"/>
+                      <a:tailEnd type="none" w="med" len="med"/>
+                    </a:lnL>
+                    <a:lnR w="12700" cap="flat" cmpd="sng" algn="ctr">
+                      <a:solidFill>
+                        <a:schemeClr val="tx1"/>
+                      </a:solidFill>
+                      <a:prstDash val="solid"/>
+                      <a:round/>
+                      <a:headEnd type="none" w="med" len="med"/>
+                      <a:tailEnd type="none" w="med" len="med"/>
+                    </a:lnR>
+                    <a:lnT w="12700" cap="flat" cmpd="sng" algn="ctr">
+                      <a:solidFill>
+                        <a:schemeClr val="tx1"/>
+                      </a:solidFill>
+                      <a:prstDash val="solid"/>
+                      <a:round/>
+                      <a:headEnd type="none" w="med" len="med"/>
+                      <a:tailEnd type="none" w="med" len="med"/>
+                    </a:lnT>
+                    <a:lnB w="12700" cap="flat" cmpd="sng" algn="ctr">
+                      <a:solidFill>
+                        <a:schemeClr val="tx1"/>
+                      </a:solidFill>
+                      <a:prstDash val="solid"/>
+                      <a:round/>
+                      <a:headEnd type="none" w="med" len="med"/>
+                      <a:tailEnd type="none" w="med" len="med"/>
+                    </a:lnB>
+                    <a:noFill/>
+                  </a:tcPr>
+                </a:tc>
+                <a:tc>
+                  <a:txBody>
+                    <a:bodyPr/>
+                    <a:lstStyle/>
+                    <a:p>
+                      <a:r>
+                        <a:rPr lang="en-US"/>
+                        <a:t>Hal-hazırda login olmuş istifadəçini qaytarır (User obyekti)</a:t>
+                      </a:r>
+                    </a:p>
+                  </a:txBody>
+                  <a:tcPr anchor="ctr">
+                    <a:lnL w="12700" cap="flat" cmpd="sng" algn="ctr">
+                      <a:solidFill>
+                        <a:schemeClr val="tx1"/>
+                      </a:solidFill>
+                      <a:prstDash val="solid"/>
+                      <a:round/>
+                      <a:headEnd type="none" w="med" len="med"/>
+                      <a:tailEnd type="none" w="med" len="med"/>
+                    </a:lnL>
+                    <a:lnR w="12700" cap="flat" cmpd="sng" algn="ctr">
+                      <a:solidFill>
+                        <a:schemeClr val="tx1"/>
+                      </a:solidFill>
+                      <a:prstDash val="solid"/>
+                      <a:round/>
+                      <a:headEnd type="none" w="med" len="med"/>
+                      <a:tailEnd type="none" w="med" len="med"/>
+                    </a:lnR>
+                    <a:lnT w="12700" cap="flat" cmpd="sng" algn="ctr">
+                      <a:solidFill>
+                        <a:schemeClr val="tx1"/>
+                      </a:solidFill>
+                      <a:prstDash val="solid"/>
+                      <a:round/>
+                      <a:headEnd type="none" w="med" len="med"/>
+                      <a:tailEnd type="none" w="med" len="med"/>
+                    </a:lnT>
+                    <a:lnB w="12700" cap="flat" cmpd="sng" algn="ctr">
+                      <a:solidFill>
+                        <a:schemeClr val="tx1"/>
+                      </a:solidFill>
+                      <a:prstDash val="solid"/>
+                      <a:round/>
+                      <a:headEnd type="none" w="med" len="med"/>
+                      <a:tailEnd type="none" w="med" len="med"/>
+                    </a:lnB>
+                    <a:noFill/>
+                  </a:tcPr>
+                </a:tc>
+                <a:extLst>
+                  <a:ext uri="{0D108BD9-81ED-4DB2-BD59-A6C34878D82A}">
+                    <a16:rowId xmlns:a16="http://schemas.microsoft.com/office/drawing/2014/main" val="2862346270"/>
+                  </a:ext>
+                </a:extLst>
+              </a:tr>
+              <a:tr h="403580">
+                <a:tc>
+                  <a:txBody>
+                    <a:bodyPr/>
+                    <a:lstStyle/>
+                    <a:p>
+                      <a:r>
+                        <a:rPr lang="en-US" b="1">
+                          <a:solidFill>
+                            <a:srgbClr val="FF0000"/>
+                          </a:solidFill>
+                        </a:rPr>
+                        <a:t>auth()</a:t>
+                      </a:r>
+                      <a:r>
+                        <a:rPr lang="en-US" b="1">
+                          <a:solidFill>
+                            <a:schemeClr val="tx1"/>
+                          </a:solidFill>
+                        </a:rPr>
+                        <a:t>-&gt;</a:t>
+                      </a:r>
+                      <a:r>
+                        <a:rPr lang="en-US" b="1">
+                          <a:solidFill>
+                            <a:srgbClr val="FF0000"/>
+                          </a:solidFill>
+                        </a:rPr>
+                        <a:t>user()</a:t>
+                      </a:r>
+                    </a:p>
+                  </a:txBody>
+                  <a:tcPr anchor="ctr">
+                    <a:lnL w="12700" cap="flat" cmpd="sng" algn="ctr">
+                      <a:solidFill>
+                        <a:schemeClr val="tx1"/>
+                      </a:solidFill>
+                      <a:prstDash val="solid"/>
+                      <a:round/>
+                      <a:headEnd type="none" w="med" len="med"/>
+                      <a:tailEnd type="none" w="med" len="med"/>
+                    </a:lnL>
+                    <a:lnR w="12700" cap="flat" cmpd="sng" algn="ctr">
+                      <a:solidFill>
+                        <a:schemeClr val="tx1"/>
+                      </a:solidFill>
+                      <a:prstDash val="solid"/>
+                      <a:round/>
+                      <a:headEnd type="none" w="med" len="med"/>
+                      <a:tailEnd type="none" w="med" len="med"/>
+                    </a:lnR>
+                    <a:lnT w="12700" cap="flat" cmpd="sng" algn="ctr">
+                      <a:solidFill>
+                        <a:schemeClr val="tx1"/>
+                      </a:solidFill>
+                      <a:prstDash val="solid"/>
+                      <a:round/>
+                      <a:headEnd type="none" w="med" len="med"/>
+                      <a:tailEnd type="none" w="med" len="med"/>
+                    </a:lnT>
+                    <a:lnB w="12700" cap="flat" cmpd="sng" algn="ctr">
+                      <a:solidFill>
+                        <a:schemeClr val="tx1"/>
+                      </a:solidFill>
+                      <a:prstDash val="solid"/>
+                      <a:round/>
+                      <a:headEnd type="none" w="med" len="med"/>
+                      <a:tailEnd type="none" w="med" len="med"/>
+                    </a:lnB>
+                    <a:noFill/>
+                  </a:tcPr>
+                </a:tc>
+                <a:tc>
+                  <a:txBody>
+                    <a:bodyPr/>
+                    <a:lstStyle/>
+                    <a:p>
+                      <a:r>
+                        <a:rPr lang="en-US"/>
+                        <a:t>Eyni işi görür (helper forması)</a:t>
+                      </a:r>
+                    </a:p>
+                  </a:txBody>
+                  <a:tcPr anchor="ctr">
+                    <a:lnL w="12700" cap="flat" cmpd="sng" algn="ctr">
+                      <a:solidFill>
+                        <a:schemeClr val="tx1"/>
+                      </a:solidFill>
+                      <a:prstDash val="solid"/>
+                      <a:round/>
+                      <a:headEnd type="none" w="med" len="med"/>
+                      <a:tailEnd type="none" w="med" len="med"/>
+                    </a:lnL>
+                    <a:lnR w="12700" cap="flat" cmpd="sng" algn="ctr">
+                      <a:solidFill>
+                        <a:schemeClr val="tx1"/>
+                      </a:solidFill>
+                      <a:prstDash val="solid"/>
+                      <a:round/>
+                      <a:headEnd type="none" w="med" len="med"/>
+                      <a:tailEnd type="none" w="med" len="med"/>
+                    </a:lnR>
+                    <a:lnT w="12700" cap="flat" cmpd="sng" algn="ctr">
+                      <a:solidFill>
+                        <a:schemeClr val="tx1"/>
+                      </a:solidFill>
+                      <a:prstDash val="solid"/>
+                      <a:round/>
+                      <a:headEnd type="none" w="med" len="med"/>
+                      <a:tailEnd type="none" w="med" len="med"/>
+                    </a:lnT>
+                    <a:lnB w="12700" cap="flat" cmpd="sng" algn="ctr">
+                      <a:solidFill>
+                        <a:schemeClr val="tx1"/>
+                      </a:solidFill>
+                      <a:prstDash val="solid"/>
+                      <a:round/>
+                      <a:headEnd type="none" w="med" len="med"/>
+                      <a:tailEnd type="none" w="med" len="med"/>
+                    </a:lnB>
+                    <a:noFill/>
+                  </a:tcPr>
+                </a:tc>
+                <a:extLst>
+                  <a:ext uri="{0D108BD9-81ED-4DB2-BD59-A6C34878D82A}">
+                    <a16:rowId xmlns:a16="http://schemas.microsoft.com/office/drawing/2014/main" val="1516462663"/>
+                  </a:ext>
+                </a:extLst>
+              </a:tr>
+              <a:tr h="403580">
+                <a:tc>
+                  <a:txBody>
+                    <a:bodyPr/>
+                    <a:lstStyle/>
+                    <a:p>
+                      <a:r>
+                        <a:rPr lang="en-US" b="1">
+                          <a:solidFill>
+                            <a:srgbClr val="FF0000"/>
+                          </a:solidFill>
+                        </a:rPr>
+                        <a:t>auth()</a:t>
+                      </a:r>
+                      <a:r>
+                        <a:rPr lang="en-US" b="1">
+                          <a:solidFill>
+                            <a:schemeClr val="tx1"/>
+                          </a:solidFill>
+                        </a:rPr>
+                        <a:t>-&gt;</a:t>
+                      </a:r>
+                      <a:r>
+                        <a:rPr lang="en-US" b="1">
+                          <a:solidFill>
+                            <a:srgbClr val="FF0000"/>
+                          </a:solidFill>
+                        </a:rPr>
+                        <a:t>user()</a:t>
+                      </a:r>
+                      <a:r>
+                        <a:rPr lang="en-US" b="1">
+                          <a:solidFill>
+                            <a:schemeClr val="tx1"/>
+                          </a:solidFill>
+                        </a:rPr>
+                        <a:t>-&gt;</a:t>
+                      </a:r>
+                      <a:r>
+                        <a:rPr lang="en-US" b="1">
+                          <a:solidFill>
+                            <a:srgbClr val="FF0000"/>
+                          </a:solidFill>
+                        </a:rPr>
+                        <a:t>name</a:t>
+                      </a:r>
+                    </a:p>
+                  </a:txBody>
+                  <a:tcPr anchor="ctr">
+                    <a:lnL w="12700" cap="flat" cmpd="sng" algn="ctr">
+                      <a:solidFill>
+                        <a:schemeClr val="tx1"/>
+                      </a:solidFill>
+                      <a:prstDash val="solid"/>
+                      <a:round/>
+                      <a:headEnd type="none" w="med" len="med"/>
+                      <a:tailEnd type="none" w="med" len="med"/>
+                    </a:lnL>
+                    <a:lnR w="12700" cap="flat" cmpd="sng" algn="ctr">
+                      <a:solidFill>
+                        <a:schemeClr val="tx1"/>
+                      </a:solidFill>
+                      <a:prstDash val="solid"/>
+                      <a:round/>
+                      <a:headEnd type="none" w="med" len="med"/>
+                      <a:tailEnd type="none" w="med" len="med"/>
+                    </a:lnR>
+                    <a:lnT w="12700" cap="flat" cmpd="sng" algn="ctr">
+                      <a:solidFill>
+                        <a:schemeClr val="tx1"/>
+                      </a:solidFill>
+                      <a:prstDash val="solid"/>
+                      <a:round/>
+                      <a:headEnd type="none" w="med" len="med"/>
+                      <a:tailEnd type="none" w="med" len="med"/>
+                    </a:lnT>
+                    <a:lnB w="12700" cap="flat" cmpd="sng" algn="ctr">
+                      <a:solidFill>
+                        <a:schemeClr val="tx1"/>
+                      </a:solidFill>
+                      <a:prstDash val="solid"/>
+                      <a:round/>
+                      <a:headEnd type="none" w="med" len="med"/>
+                      <a:tailEnd type="none" w="med" len="med"/>
+                    </a:lnB>
+                    <a:noFill/>
+                  </a:tcPr>
+                </a:tc>
+                <a:tc>
+                  <a:txBody>
+                    <a:bodyPr/>
+                    <a:lstStyle/>
+                    <a:p>
+                      <a:r>
+                        <a:rPr lang="en-US"/>
+                        <a:t>İstifadəçinin adını verir</a:t>
+                      </a:r>
+                    </a:p>
+                  </a:txBody>
+                  <a:tcPr anchor="ctr">
+                    <a:lnL w="12700" cap="flat" cmpd="sng" algn="ctr">
+                      <a:solidFill>
+                        <a:schemeClr val="tx1"/>
+                      </a:solidFill>
+                      <a:prstDash val="solid"/>
+                      <a:round/>
+                      <a:headEnd type="none" w="med" len="med"/>
+                      <a:tailEnd type="none" w="med" len="med"/>
+                    </a:lnL>
+                    <a:lnR w="12700" cap="flat" cmpd="sng" algn="ctr">
+                      <a:solidFill>
+                        <a:schemeClr val="tx1"/>
+                      </a:solidFill>
+                      <a:prstDash val="solid"/>
+                      <a:round/>
+                      <a:headEnd type="none" w="med" len="med"/>
+                      <a:tailEnd type="none" w="med" len="med"/>
+                    </a:lnR>
+                    <a:lnT w="12700" cap="flat" cmpd="sng" algn="ctr">
+                      <a:solidFill>
+                        <a:schemeClr val="tx1"/>
+                      </a:solidFill>
+                      <a:prstDash val="solid"/>
+                      <a:round/>
+                      <a:headEnd type="none" w="med" len="med"/>
+                      <a:tailEnd type="none" w="med" len="med"/>
+                    </a:lnT>
+                    <a:lnB w="12700" cap="flat" cmpd="sng" algn="ctr">
+                      <a:solidFill>
+                        <a:schemeClr val="tx1"/>
+                      </a:solidFill>
+                      <a:prstDash val="solid"/>
+                      <a:round/>
+                      <a:headEnd type="none" w="med" len="med"/>
+                      <a:tailEnd type="none" w="med" len="med"/>
+                    </a:lnB>
+                    <a:noFill/>
+                  </a:tcPr>
+                </a:tc>
+                <a:extLst>
+                  <a:ext uri="{0D108BD9-81ED-4DB2-BD59-A6C34878D82A}">
+                    <a16:rowId xmlns:a16="http://schemas.microsoft.com/office/drawing/2014/main" val="852232440"/>
+                  </a:ext>
+                </a:extLst>
+              </a:tr>
+              <a:tr h="403580">
+                <a:tc>
+                  <a:txBody>
+                    <a:bodyPr/>
+                    <a:lstStyle/>
+                    <a:p>
+                      <a:r>
+                        <a:rPr lang="en-US" b="1">
+                          <a:solidFill>
+                            <a:srgbClr val="FF0000"/>
+                          </a:solidFill>
+                        </a:rPr>
+                        <a:t>auth()</a:t>
+                      </a:r>
+                      <a:r>
+                        <a:rPr lang="en-US" b="1">
+                          <a:solidFill>
+                            <a:schemeClr val="tx1"/>
+                          </a:solidFill>
+                        </a:rPr>
+                        <a:t>-&gt;</a:t>
+                      </a:r>
+                      <a:r>
+                        <a:rPr lang="en-US" b="1">
+                          <a:solidFill>
+                            <a:srgbClr val="FF0000"/>
+                          </a:solidFill>
+                        </a:rPr>
+                        <a:t>user()</a:t>
+                      </a:r>
+                      <a:r>
+                        <a:rPr lang="en-US" b="1">
+                          <a:solidFill>
+                            <a:schemeClr val="tx1"/>
+                          </a:solidFill>
+                        </a:rPr>
+                        <a:t>-&gt;</a:t>
+                      </a:r>
+                      <a:r>
+                        <a:rPr lang="en-US" b="1">
+                          <a:solidFill>
+                            <a:srgbClr val="FF0000"/>
+                          </a:solidFill>
+                        </a:rPr>
+                        <a:t>email</a:t>
+                      </a:r>
+                    </a:p>
+                  </a:txBody>
+                  <a:tcPr anchor="ctr">
+                    <a:lnL w="12700" cap="flat" cmpd="sng" algn="ctr">
+                      <a:solidFill>
+                        <a:schemeClr val="tx1"/>
+                      </a:solidFill>
+                      <a:prstDash val="solid"/>
+                      <a:round/>
+                      <a:headEnd type="none" w="med" len="med"/>
+                      <a:tailEnd type="none" w="med" len="med"/>
+                    </a:lnL>
+                    <a:lnR w="12700" cap="flat" cmpd="sng" algn="ctr">
+                      <a:solidFill>
+                        <a:schemeClr val="tx1"/>
+                      </a:solidFill>
+                      <a:prstDash val="solid"/>
+                      <a:round/>
+                      <a:headEnd type="none" w="med" len="med"/>
+                      <a:tailEnd type="none" w="med" len="med"/>
+                    </a:lnR>
+                    <a:lnT w="12700" cap="flat" cmpd="sng" algn="ctr">
+                      <a:solidFill>
+                        <a:schemeClr val="tx1"/>
+                      </a:solidFill>
+                      <a:prstDash val="solid"/>
+                      <a:round/>
+                      <a:headEnd type="none" w="med" len="med"/>
+                      <a:tailEnd type="none" w="med" len="med"/>
+                    </a:lnT>
+                    <a:lnB w="12700" cap="flat" cmpd="sng" algn="ctr">
+                      <a:solidFill>
+                        <a:schemeClr val="tx1"/>
+                      </a:solidFill>
+                      <a:prstDash val="solid"/>
+                      <a:round/>
+                      <a:headEnd type="none" w="med" len="med"/>
+                      <a:tailEnd type="none" w="med" len="med"/>
+                    </a:lnB>
+                    <a:noFill/>
+                  </a:tcPr>
+                </a:tc>
+                <a:tc>
+                  <a:txBody>
+                    <a:bodyPr/>
+                    <a:lstStyle/>
+                    <a:p>
+                      <a:r>
+                        <a:rPr lang="en-US"/>
+                        <a:t>İstifadəçinin emailini verir</a:t>
+                      </a:r>
+                    </a:p>
+                  </a:txBody>
+                  <a:tcPr anchor="ctr">
+                    <a:lnL w="12700" cap="flat" cmpd="sng" algn="ctr">
+                      <a:solidFill>
+                        <a:schemeClr val="tx1"/>
+                      </a:solidFill>
+                      <a:prstDash val="solid"/>
+                      <a:round/>
+                      <a:headEnd type="none" w="med" len="med"/>
+                      <a:tailEnd type="none" w="med" len="med"/>
+                    </a:lnL>
+                    <a:lnR w="12700" cap="flat" cmpd="sng" algn="ctr">
+                      <a:solidFill>
+                        <a:schemeClr val="tx1"/>
+                      </a:solidFill>
+                      <a:prstDash val="solid"/>
+                      <a:round/>
+                      <a:headEnd type="none" w="med" len="med"/>
+                      <a:tailEnd type="none" w="med" len="med"/>
+                    </a:lnR>
+                    <a:lnT w="12700" cap="flat" cmpd="sng" algn="ctr">
+                      <a:solidFill>
+                        <a:schemeClr val="tx1"/>
+                      </a:solidFill>
+                      <a:prstDash val="solid"/>
+                      <a:round/>
+                      <a:headEnd type="none" w="med" len="med"/>
+                      <a:tailEnd type="none" w="med" len="med"/>
+                    </a:lnT>
+                    <a:lnB w="12700" cap="flat" cmpd="sng" algn="ctr">
+                      <a:solidFill>
+                        <a:schemeClr val="tx1"/>
+                      </a:solidFill>
+                      <a:prstDash val="solid"/>
+                      <a:round/>
+                      <a:headEnd type="none" w="med" len="med"/>
+                      <a:tailEnd type="none" w="med" len="med"/>
+                    </a:lnB>
+                    <a:noFill/>
+                  </a:tcPr>
+                </a:tc>
+                <a:extLst>
+                  <a:ext uri="{0D108BD9-81ED-4DB2-BD59-A6C34878D82A}">
+                    <a16:rowId xmlns:a16="http://schemas.microsoft.com/office/drawing/2014/main" val="4230767517"/>
+                  </a:ext>
+                </a:extLst>
+              </a:tr>
+              <a:tr h="403580">
+                <a:tc>
+                  <a:txBody>
+                    <a:bodyPr/>
+                    <a:lstStyle/>
+                    <a:p>
+                      <a:r>
+                        <a:rPr lang="en-US" b="1">
+                          <a:solidFill>
+                            <a:srgbClr val="FF0000"/>
+                          </a:solidFill>
+                        </a:rPr>
+                        <a:t>auth()</a:t>
+                      </a:r>
+                      <a:r>
+                        <a:rPr lang="en-US" b="1">
+                          <a:solidFill>
+                            <a:schemeClr val="tx1"/>
+                          </a:solidFill>
+                        </a:rPr>
+                        <a:t>-&gt;</a:t>
+                      </a:r>
+                      <a:r>
+                        <a:rPr lang="en-US" b="1">
+                          <a:solidFill>
+                            <a:srgbClr val="FF0000"/>
+                          </a:solidFill>
+                        </a:rPr>
+                        <a:t>check()</a:t>
+                      </a:r>
+                    </a:p>
+                  </a:txBody>
+                  <a:tcPr anchor="ctr">
+                    <a:lnL w="12700" cap="flat" cmpd="sng" algn="ctr">
+                      <a:solidFill>
+                        <a:schemeClr val="tx1"/>
+                      </a:solidFill>
+                      <a:prstDash val="solid"/>
+                      <a:round/>
+                      <a:headEnd type="none" w="med" len="med"/>
+                      <a:tailEnd type="none" w="med" len="med"/>
+                    </a:lnL>
+                    <a:lnR w="12700" cap="flat" cmpd="sng" algn="ctr">
+                      <a:solidFill>
+                        <a:schemeClr val="tx1"/>
+                      </a:solidFill>
+                      <a:prstDash val="solid"/>
+                      <a:round/>
+                      <a:headEnd type="none" w="med" len="med"/>
+                      <a:tailEnd type="none" w="med" len="med"/>
+                    </a:lnR>
+                    <a:lnT w="12700" cap="flat" cmpd="sng" algn="ctr">
+                      <a:solidFill>
+                        <a:schemeClr val="tx1"/>
+                      </a:solidFill>
+                      <a:prstDash val="solid"/>
+                      <a:round/>
+                      <a:headEnd type="none" w="med" len="med"/>
+                      <a:tailEnd type="none" w="med" len="med"/>
+                    </a:lnT>
+                    <a:lnB w="12700" cap="flat" cmpd="sng" algn="ctr">
+                      <a:solidFill>
+                        <a:schemeClr val="tx1"/>
+                      </a:solidFill>
+                      <a:prstDash val="solid"/>
+                      <a:round/>
+                      <a:headEnd type="none" w="med" len="med"/>
+                      <a:tailEnd type="none" w="med" len="med"/>
+                    </a:lnB>
+                    <a:noFill/>
+                  </a:tcPr>
+                </a:tc>
+                <a:tc>
+                  <a:txBody>
+                    <a:bodyPr/>
+                    <a:lstStyle/>
+                    <a:p>
+                      <a:r>
+                        <a:rPr lang="en-US"/>
+                        <a:t>İstifadəçi login olubmu (true/false)</a:t>
+                      </a:r>
+                    </a:p>
+                  </a:txBody>
+                  <a:tcPr anchor="ctr">
+                    <a:lnL w="12700" cap="flat" cmpd="sng" algn="ctr">
+                      <a:solidFill>
+                        <a:schemeClr val="tx1"/>
+                      </a:solidFill>
+                      <a:prstDash val="solid"/>
+                      <a:round/>
+                      <a:headEnd type="none" w="med" len="med"/>
+                      <a:tailEnd type="none" w="med" len="med"/>
+                    </a:lnL>
+                    <a:lnR w="12700" cap="flat" cmpd="sng" algn="ctr">
+                      <a:solidFill>
+                        <a:schemeClr val="tx1"/>
+                      </a:solidFill>
+                      <a:prstDash val="solid"/>
+                      <a:round/>
+                      <a:headEnd type="none" w="med" len="med"/>
+                      <a:tailEnd type="none" w="med" len="med"/>
+                    </a:lnR>
+                    <a:lnT w="12700" cap="flat" cmpd="sng" algn="ctr">
+                      <a:solidFill>
+                        <a:schemeClr val="tx1"/>
+                      </a:solidFill>
+                      <a:prstDash val="solid"/>
+                      <a:round/>
+                      <a:headEnd type="none" w="med" len="med"/>
+                      <a:tailEnd type="none" w="med" len="med"/>
+                    </a:lnT>
+                    <a:lnB w="12700" cap="flat" cmpd="sng" algn="ctr">
+                      <a:solidFill>
+                        <a:schemeClr val="tx1"/>
+                      </a:solidFill>
+                      <a:prstDash val="solid"/>
+                      <a:round/>
+                      <a:headEnd type="none" w="med" len="med"/>
+                      <a:tailEnd type="none" w="med" len="med"/>
+                    </a:lnB>
+                    <a:noFill/>
+                  </a:tcPr>
+                </a:tc>
+                <a:extLst>
+                  <a:ext uri="{0D108BD9-81ED-4DB2-BD59-A6C34878D82A}">
+                    <a16:rowId xmlns:a16="http://schemas.microsoft.com/office/drawing/2014/main" val="2663955509"/>
+                  </a:ext>
+                </a:extLst>
+              </a:tr>
+            </a:tbl>
+          </a:graphicData>
+        </a:graphic>
+      </p:graphicFrame>
     </p:spTree>
     <p:extLst>
       <p:ext uri="{BB962C8B-B14F-4D97-AF65-F5344CB8AC3E}">

</xml_diff>